<commit_message>
docs-site: describe product behavior without ADR references
Removes ADR numbers, decision-record links and decision-history
narration from the product guide in all four locales, rewrites the
decisions FAQ as a design-principles FAQ, and strips the same references
from the release notes and the intro deck (pptx regenerated with its
builder; HTML edited in step with its Markdown source).

Co-Authored-By: Claude Opus 5.5 <noreply@anthropic.com>
</commit_message>
<xml_diff>
--- a/docs-site/static/presentation/awsops-intro/awsops-intro.pptx
+++ b/docs-site/static/presentation/awsops-intro/awsops-intro.pptx
@@ -728,8 +728,6 @@
 • PKCE(Proof Key for Code Exchange): 시크릿 없는 공개 클라이언트를 위한 OAuth 확장
 • JWKS(JSON Web Key Set): 토큰 서명 검증용 공개키 집합
 • CMK(Customer Managed Key): 고객 관리형 KMS 암호화 키
-[출처]
-• AWSops 결정 기준선 — 리포지토리 docs/decisions/BASELINE.md
 [변경 이력]
 • 2026-08-11: 초기 작성
 • 2026-08-12: AWS Light 테마 재설계</a:t>
@@ -824,12 +822,10 @@
 • 도메인별 게이트웨이 9종이 각자 전문 도구로 라이브 조회
 • 챗 16섹션 정의 = 게이트웨이 9 + aws-data + 전문 섹션 6 (로컬 7종은 현재 비활성 — 표준 라우팅 대응)
 • 라이브 AWS 조회는 AgentCore 게이트웨이 경유 원칙
-AI 레이어의 핵심은 '분업'입니다. 범용 챗봇 하나가 모든 질문을 받는 게 아니라, 네트워크·컨테이너·데이터·보안·비용·모니터링·IaC·운영·외부관측 아홉 개 도메인 게이트웨이가 각자 전문 도구를 들고 있습니다. 질문이 오면 해당 도메인 에이전트가 라이브 AWS 데이터를 직접 조회해서 답합니다. 여기에 두 가지가 더 있습니다. aws-data는 리소스 수량·목록 질문을 받는 generic 섹션이고 — 라이브 AWS 조회는 어디까지나 AgentCore 게이트웨이 경유가 원칙입니다. 그리고 유휴 리소스 스캔이나 인시던트 분석 같은 여섯 개 전문 섹션은 근거 데이터를 먼저 모으고 분석하는 자동 수집형 설계입니다 — 이 경로는 현재 설계 원칙(ADR-001/010)에 따라 비활성이며 해당 질문은 표준 라우팅이 대응합니다. 합쳐서 16개 섹션 정의입니다. 모델은 Bedrock의 Claude 계열을 용도별로 혼용합니다.
+AI 레이어의 핵심은 '분업'입니다. 범용 챗봇 하나가 모든 질문을 받는 게 아니라, 네트워크·컨테이너·데이터·보안·비용·모니터링·IaC·운영·외부관측 아홉 개 도메인 게이트웨이가 각자 전문 도구를 들고 있습니다. 질문이 오면 해당 도메인 에이전트가 라이브 AWS 데이터를 직접 조회해서 답합니다. 여기에 두 가지가 더 있습니다. aws-data는 리소스 수량·목록 질문을 받는 generic 섹션이고 — 라이브 AWS 조회는 어디까지나 AgentCore 게이트웨이 경유가 원칙입니다. 그리고 유휴 리소스 스캔이나 인시던트 분석 같은 여섯 개 전문 섹션은 근거 데이터를 먼저 모으고 분석하는 자동 수집형 설계입니다 — 이 경로는 현재 설계 원칙에 따라 비활성이며 해당 질문은 표준 라우팅이 대응합니다. 합쳐서 16개 섹션 정의입니다. 모델은 Bedrock의 Claude 계열을 용도별로 혼용합니다.
 [약어]
 • MCP(Model Context Protocol): AI 에이전트가 도구를 호출하는 표준 프로토콜
 • MSK(Managed Streaming for Apache Kafka): AWS 관리형 Kafka 서비스
-[출처]
-• AWSops 결정 기준선 — 리포지토리 docs/decisions/BASELINE.md
 [변경 이력]
 • 2026-08-11: 초기 작성
 • 2026-08-12: AWS Light 테마 재설계</a:t>
@@ -1021,14 +1017,10 @@
             <a:r>
               <a:rPr lang="en-US" dirty="0"/>
               <a:t>[요약]
-• 변경 기능은 거버넌스(ADR)로 동결 — 해제는 별도 승인 절차
+• 변경 기능은 거버넌스로 동결 — 해제는 별도 승인 절차
 • K8s 읽기 verb 한정 · 계정 연결은 ReadOnly 역할 1개 + 검증
 • AI 오답의 최악 = 틀린 조언 (틀린 변경이 아님)
-실무자 여러분께 가장 중요한 슬라이드입니다. AWSops에 변경 기능이 '없는' 것은 미완성이 아니라 설계 결정입니다. 자동 변경은 두 번째 장애의 가장 흔한 원인이고, 운영자가 도구를 신뢰하지 못하면 결국 쓰지 않게 됩니다. 그래서 변경·자동 조치 기능은 아키텍처 결정 기록으로 동결되어 있고, 해제하려면 별도 승인 절차가 필요합니다. 쿠버네티스에는 읽기 verb만 발행하고 — 온보딩 때 opt-in으로 Access Entry에 AWS 관리형 read-only 정책을 부여하는 것이 유일한 설정 변경이며 워크로드 오브젝트는 건드리지 않습니다 — 계정 연결에 요구하는 것도 읽기 전용 역할 하나뿐입니다. 유일한 문서화된 예외는 ADR-015 — 데이터베이스 시크릿 회전 때 자기 자신의 웹 서비스를 재시작하는 것 하나이며, 기본 꺼짐에 IAM도 해당 서비스 ARN 하나로 한정됩니다. 등록 시점에 실제로 역할을 assume해 봐서 성공해야만 연결됩니다. 이 원칙 덕분에 AI가 틀려도 최악의 경우가 '틀린 조언'입니다 — 인프라에는 아무 일도 일어나지 않습니다. 변경은 사람과 기존 IaC 파이프라인의 몫으로 남기고, AWSops는 판단 근거를 극단적으로 잘 만드는 데 집중합니다.
-[약어]
-• ADR(Architecture Decision Record): 아키텍처 결정과 근거를 남기는 공식 기록
-[출처]
-• AWSops 결정 기준선 — 리포지토리 docs/decisions/BASELINE.md
+실무자 여러분께 가장 중요한 슬라이드입니다. AWSops에 변경 기능이 '없는' 것은 미완성이 아니라 설계 결정입니다. 자동 변경은 두 번째 장애의 가장 흔한 원인이고, 운영자가 도구를 신뢰하지 못하면 결국 쓰지 않게 됩니다. 그래서 변경·자동 조치 기능은 제품 정책으로 동결되어 있고, 해제하려면 별도 승인 절차가 필요합니다. 쿠버네티스에는 읽기 verb만 발행하고 — 온보딩 때 opt-in으로 Access Entry에 AWS 관리형 read-only 정책을 부여하는 것이 유일한 설정 변경이며 워크로드 오브젝트는 건드리지 않습니다 — 계정 연결에 요구하는 것도 읽기 전용 역할 하나뿐입니다. 유일한 문서화된 예외는 데이터베이스 시크릿 회전 때 자기 자신의 웹 서비스를 재시작하는 것 하나이며, 기본 꺼짐에 IAM도 해당 서비스 ARN 하나로 한정됩니다. 등록 시점에 실제로 역할을 assume해 봐서 성공해야만 연결됩니다. 이 원칙 덕분에 AI가 틀려도 최악의 경우가 '틀린 조언'입니다 — 인프라에는 아무 일도 일어나지 않습니다. 변경은 사람과 기존 IaC 파이프라인의 몫으로 남기고, AWSops는 판단 근거를 극단적으로 잘 만드는 데 집중합니다.
 [변경 이력]
 • 2026-08-11: 초기 작성
 • 2026-08-12: AWS Light 테마 재설계</a:t>
@@ -7678,7 +7670,7 @@
                 <a:ea typeface="Pretendard" pitchFamily="34" charset="-122"/>
                 <a:cs typeface="Pretendard" pitchFamily="34" charset="-120"/>
               </a:rPr>
-              <a:t>"리전별 EC2 몇 개야?" 같은 수량·목록 질문을 받는 generic 섹션. 라이브 AWS 조회는 AgentCore 게이트웨이 경유가 원칙(ADR-001/010) — 별도 SQL 라이브 실행 경로는 설계상 차단</a:t>
+              <a:t>"리전별 EC2 몇 개야?" 같은 수량·목록 질문을 받는 generic 섹션. 라이브 AWS 조회는 AgentCore 게이트웨이 경유가 원칙 — 별도 SQL 라이브 실행 경로는 설계상 차단</a:t>
             </a:r>
             <a:endParaRPr lang="en-US" sz="1000" dirty="0"/>
           </a:p>
@@ -7837,7 +7829,7 @@
                 <a:ea typeface="Pretendard" pitchFamily="34" charset="-122"/>
                 <a:cs typeface="Pretendard" pitchFamily="34" charset="-120"/>
               </a:rPr>
-              <a:t>유휴 리소스 스캔 · EKS/DB/MSK 최적화 · 지연 분석 · 인시던트 — 근거 데이터를 먼저 모으고 분석하는 설계 — 현재는 설계 원칙(ADR-001/010)에 따라 비활성, 표준 라우팅으로 대응. 총 16개 챗 섹션 구성</a:t>
+              <a:t>유휴 리소스 스캔 · EKS/DB/MSK 최적화 · 지연 분석 · 인시던트 — 근거 데이터를 먼저 모으고 분석하는 설계 — 현재는 설계 원칙에 따라 비활성, 표준 라우팅으로 대응. 총 16개 챗 섹션 구성</a:t>
             </a:r>
             <a:endParaRPr lang="en-US" sz="1000" dirty="0"/>
           </a:p>
@@ -9960,7 +9952,7 @@
                 <a:ea typeface="Pretendard" pitchFamily="34" charset="-122"/>
                 <a:cs typeface="Pretendard" pitchFamily="34" charset="-120"/>
               </a:rPr>
-              <a:t>변경·자동 조치·코드 배포 기능은 아키텍처 결정 기록(ADR)으로 동결 — 해제는 별도 승인 절차가 필요한 제품 결정. 단일 문서화 예외(ADR-015): 시크릿 회전 시 자기 웹 서비스 재시작(기본 꺼짐, IAM 1개 ARN 한정)</a:t>
+              <a:t>변경·자동 조치·코드 배포 기능은 제품 정책으로 동결 — 해제는 별도 승인 절차가 필요한 제품 결정. 단일 문서화 예외: 시크릿 회전 시 자기 웹 서비스 재시작(기본 꺼짐, IAM 1개 ARN 한정)</a:t>
             </a:r>
             <a:endParaRPr lang="en-US" sz="1000" dirty="0"/>
           </a:p>
@@ -10554,7 +10546,7 @@
                 <a:ea typeface="Pretendard" pitchFamily="34" charset="-122"/>
                 <a:cs typeface="Pretendard" pitchFamily="34" charset="-120"/>
               </a:rPr>
-              <a:t>문서화된 예외 — 자기 웹 재시작 (ADR-015 · 기본 off)</a:t>
+              <a:t>문서화된 예외 — 자기 웹 재시작 (기본 off)</a:t>
             </a:r>
             <a:endParaRPr lang="en-US" sz="900" dirty="0"/>
           </a:p>
@@ -18178,7 +18170,7 @@
                 <a:ea typeface="Pretendard" pitchFamily="34" charset="-122"/>
                 <a:cs typeface="Pretendard" pitchFamily="34" charset="-120"/>
               </a:rPr>
-              <a:t>읽기 전용 역할 하나입니다. 3rd-party 연결에는 ExternalId로 혼동 대리인을 차단하고, 등록 시점에 실제 assume 검증을 통과해야 연결됩니다. 모니터링 대상 계정에는 쓰기 권한을 요구하지도, 받지도 않습니다(호스트 자신에 대한 단일 문서화 예외는 ADR-015 웹 재시작뿐).</a:t>
+              <a:t>읽기 전용 역할 하나입니다. 3rd-party 연결에는 ExternalId로 혼동 대리인을 차단하고, 등록 시점에 실제 assume 검증을 통과해야 연결됩니다. 모니터링 대상 계정에는 쓰기 권한을 요구하지도, 받지도 않습니다(호스트 자신에 대한 단일 문서화 예외는 웹 재시작뿐).</a:t>
             </a:r>
             <a:endParaRPr lang="en-US" sz="1050" dirty="0"/>
           </a:p>

</xml_diff>

<commit_message>
docs-site: remove ADR references from the deck sources and builder
Regenerates awsops-intro.pptx with scripts/pptx/build-awsops-intro-pptx.js
(verify-deck.sh passes); HTML is edited in step with its Markdown source.

Split from #192 to stay under the AI review input limit.

Co-Authored-By: Claude Opus 5.5 <noreply@anthropic.com>
</commit_message>
<xml_diff>
--- a/docs-site/static/presentation/awsops-intro/awsops-intro.pptx
+++ b/docs-site/static/presentation/awsops-intro/awsops-intro.pptx
@@ -728,8 +728,6 @@
 • PKCE(Proof Key for Code Exchange): 시크릿 없는 공개 클라이언트를 위한 OAuth 확장
 • JWKS(JSON Web Key Set): 토큰 서명 검증용 공개키 집합
 • CMK(Customer Managed Key): 고객 관리형 KMS 암호화 키
-[출처]
-• AWSops 결정 기준선 — 리포지토리 docs/decisions/BASELINE.md
 [변경 이력]
 • 2026-08-11: 초기 작성
 • 2026-08-12: AWS Light 테마 재설계</a:t>
@@ -824,12 +822,10 @@
 • 도메인별 게이트웨이 9종이 각자 전문 도구로 라이브 조회
 • 챗 16섹션 정의 = 게이트웨이 9 + aws-data + 전문 섹션 6 (로컬 7종은 현재 비활성 — 표준 라우팅 대응)
 • 라이브 AWS 조회는 AgentCore 게이트웨이 경유 원칙
-AI 레이어의 핵심은 '분업'입니다. 범용 챗봇 하나가 모든 질문을 받는 게 아니라, 네트워크·컨테이너·데이터·보안·비용·모니터링·IaC·운영·외부관측 아홉 개 도메인 게이트웨이가 각자 전문 도구를 들고 있습니다. 질문이 오면 해당 도메인 에이전트가 라이브 AWS 데이터를 직접 조회해서 답합니다. 여기에 두 가지가 더 있습니다. aws-data는 리소스 수량·목록 질문을 받는 generic 섹션이고 — 라이브 AWS 조회는 어디까지나 AgentCore 게이트웨이 경유가 원칙입니다. 그리고 유휴 리소스 스캔이나 인시던트 분석 같은 여섯 개 전문 섹션은 근거 데이터를 먼저 모으고 분석하는 자동 수집형 설계입니다 — 이 경로는 현재 설계 원칙(ADR-001/010)에 따라 비활성이며 해당 질문은 표준 라우팅이 대응합니다. 합쳐서 16개 섹션 정의입니다. 모델은 Bedrock의 Claude 계열을 용도별로 혼용합니다.
+AI 레이어의 핵심은 '분업'입니다. 범용 챗봇 하나가 모든 질문을 받는 게 아니라, 네트워크·컨테이너·데이터·보안·비용·모니터링·IaC·운영·외부관측 아홉 개 도메인 게이트웨이가 각자 전문 도구를 들고 있습니다. 질문이 오면 해당 도메인 에이전트가 라이브 AWS 데이터를 직접 조회해서 답합니다. 여기에 두 가지가 더 있습니다. aws-data는 리소스 수량·목록 질문을 받는 generic 섹션이고 — 라이브 AWS 조회는 어디까지나 AgentCore 게이트웨이 경유가 원칙입니다. 그리고 유휴 리소스 스캔이나 인시던트 분석 같은 여섯 개 전문 섹션은 근거 데이터를 먼저 모으고 분석하는 자동 수집형 설계입니다 — 이 경로는 현재 설계 원칙에 따라 비활성이며 해당 질문은 표준 라우팅이 대응합니다. 합쳐서 16개 섹션 정의입니다. 모델은 Bedrock의 Claude 계열을 용도별로 혼용합니다.
 [약어]
 • MCP(Model Context Protocol): AI 에이전트가 도구를 호출하는 표준 프로토콜
 • MSK(Managed Streaming for Apache Kafka): AWS 관리형 Kafka 서비스
-[출처]
-• AWSops 결정 기준선 — 리포지토리 docs/decisions/BASELINE.md
 [변경 이력]
 • 2026-08-11: 초기 작성
 • 2026-08-12: AWS Light 테마 재설계</a:t>
@@ -1021,14 +1017,10 @@
             <a:r>
               <a:rPr lang="en-US" dirty="0"/>
               <a:t>[요약]
-• 변경 기능은 거버넌스(ADR)로 동결 — 해제는 별도 승인 절차
+• 변경 기능은 거버넌스로 동결 — 해제는 별도 승인 절차
 • K8s 읽기 verb 한정 · 계정 연결은 ReadOnly 역할 1개 + 검증
 • AI 오답의 최악 = 틀린 조언 (틀린 변경이 아님)
-실무자 여러분께 가장 중요한 슬라이드입니다. AWSops에 변경 기능이 '없는' 것은 미완성이 아니라 설계 결정입니다. 자동 변경은 두 번째 장애의 가장 흔한 원인이고, 운영자가 도구를 신뢰하지 못하면 결국 쓰지 않게 됩니다. 그래서 변경·자동 조치 기능은 아키텍처 결정 기록으로 동결되어 있고, 해제하려면 별도 승인 절차가 필요합니다. 쿠버네티스에는 읽기 verb만 발행하고 — 온보딩 때 opt-in으로 Access Entry에 AWS 관리형 read-only 정책을 부여하는 것이 유일한 설정 변경이며 워크로드 오브젝트는 건드리지 않습니다 — 계정 연결에 요구하는 것도 읽기 전용 역할 하나뿐입니다. 유일한 문서화된 예외는 ADR-015 — 데이터베이스 시크릿 회전 때 자기 자신의 웹 서비스를 재시작하는 것 하나이며, 기본 꺼짐에 IAM도 해당 서비스 ARN 하나로 한정됩니다. 등록 시점에 실제로 역할을 assume해 봐서 성공해야만 연결됩니다. 이 원칙 덕분에 AI가 틀려도 최악의 경우가 '틀린 조언'입니다 — 인프라에는 아무 일도 일어나지 않습니다. 변경은 사람과 기존 IaC 파이프라인의 몫으로 남기고, AWSops는 판단 근거를 극단적으로 잘 만드는 데 집중합니다.
-[약어]
-• ADR(Architecture Decision Record): 아키텍처 결정과 근거를 남기는 공식 기록
-[출처]
-• AWSops 결정 기준선 — 리포지토리 docs/decisions/BASELINE.md
+실무자 여러분께 가장 중요한 슬라이드입니다. AWSops에 변경 기능이 '없는' 것은 미완성이 아니라 설계 결정입니다. 자동 변경은 두 번째 장애의 가장 흔한 원인이고, 운영자가 도구를 신뢰하지 못하면 결국 쓰지 않게 됩니다. 그래서 변경·자동 조치 기능은 제품 정책으로 동결되어 있고, 해제하려면 별도 승인 절차가 필요합니다. 쿠버네티스에는 읽기 verb만 발행하고 — 온보딩 때 opt-in으로 Access Entry에 AWS 관리형 read-only 정책을 부여하는 것이 유일한 설정 변경이며 워크로드 오브젝트는 건드리지 않습니다 — 계정 연결에 요구하는 것도 읽기 전용 역할 하나뿐입니다. 유일한 문서화된 예외는 데이터베이스 시크릿 회전 때 자기 자신의 웹 서비스를 재시작하는 것 하나이며, 기본 꺼짐에 IAM도 해당 서비스 ARN 하나로 한정됩니다. 등록 시점에 실제로 역할을 assume해 봐서 성공해야만 연결됩니다. 이 원칙 덕분에 AI가 틀려도 최악의 경우가 '틀린 조언'입니다 — 인프라에는 아무 일도 일어나지 않습니다. 변경은 사람과 기존 IaC 파이프라인의 몫으로 남기고, AWSops는 판단 근거를 극단적으로 잘 만드는 데 집중합니다.
 [변경 이력]
 • 2026-08-11: 초기 작성
 • 2026-08-12: AWS Light 테마 재설계</a:t>
@@ -7678,7 +7670,7 @@
                 <a:ea typeface="Pretendard" pitchFamily="34" charset="-122"/>
                 <a:cs typeface="Pretendard" pitchFamily="34" charset="-120"/>
               </a:rPr>
-              <a:t>"리전별 EC2 몇 개야?" 같은 수량·목록 질문을 받는 generic 섹션. 라이브 AWS 조회는 AgentCore 게이트웨이 경유가 원칙(ADR-001/010) — 별도 SQL 라이브 실행 경로는 설계상 차단</a:t>
+              <a:t>"리전별 EC2 몇 개야?" 같은 수량·목록 질문을 받는 generic 섹션. 라이브 AWS 조회는 AgentCore 게이트웨이 경유가 원칙 — 별도 SQL 라이브 실행 경로는 설계상 차단</a:t>
             </a:r>
             <a:endParaRPr lang="en-US" sz="1000" dirty="0"/>
           </a:p>
@@ -7837,7 +7829,7 @@
                 <a:ea typeface="Pretendard" pitchFamily="34" charset="-122"/>
                 <a:cs typeface="Pretendard" pitchFamily="34" charset="-120"/>
               </a:rPr>
-              <a:t>유휴 리소스 스캔 · EKS/DB/MSK 최적화 · 지연 분석 · 인시던트 — 근거 데이터를 먼저 모으고 분석하는 설계 — 현재는 설계 원칙(ADR-001/010)에 따라 비활성, 표준 라우팅으로 대응. 총 16개 챗 섹션 구성</a:t>
+              <a:t>유휴 리소스 스캔 · EKS/DB/MSK 최적화 · 지연 분석 · 인시던트 — 근거 데이터를 먼저 모으고 분석하는 설계 — 현재는 설계 원칙에 따라 비활성, 표준 라우팅으로 대응. 총 16개 챗 섹션 구성</a:t>
             </a:r>
             <a:endParaRPr lang="en-US" sz="1000" dirty="0"/>
           </a:p>
@@ -9960,7 +9952,7 @@
                 <a:ea typeface="Pretendard" pitchFamily="34" charset="-122"/>
                 <a:cs typeface="Pretendard" pitchFamily="34" charset="-120"/>
               </a:rPr>
-              <a:t>변경·자동 조치·코드 배포 기능은 아키텍처 결정 기록(ADR)으로 동결 — 해제는 별도 승인 절차가 필요한 제품 결정. 단일 문서화 예외(ADR-015): 시크릿 회전 시 자기 웹 서비스 재시작(기본 꺼짐, IAM 1개 ARN 한정)</a:t>
+              <a:t>변경·자동 조치·코드 배포 기능은 제품 정책으로 동결 — 해제는 별도 승인 절차가 필요한 제품 결정. 단일 문서화 예외: 시크릿 회전 시 자기 웹 서비스 재시작(기본 꺼짐, IAM 1개 ARN 한정)</a:t>
             </a:r>
             <a:endParaRPr lang="en-US" sz="1000" dirty="0"/>
           </a:p>
@@ -10554,7 +10546,7 @@
                 <a:ea typeface="Pretendard" pitchFamily="34" charset="-122"/>
                 <a:cs typeface="Pretendard" pitchFamily="34" charset="-120"/>
               </a:rPr>
-              <a:t>문서화된 예외 — 자기 웹 재시작 (ADR-015 · 기본 off)</a:t>
+              <a:t>문서화된 예외 — 자기 웹 재시작 (기본 off)</a:t>
             </a:r>
             <a:endParaRPr lang="en-US" sz="900" dirty="0"/>
           </a:p>
@@ -18178,7 +18170,7 @@
                 <a:ea typeface="Pretendard" pitchFamily="34" charset="-122"/>
                 <a:cs typeface="Pretendard" pitchFamily="34" charset="-120"/>
               </a:rPr>
-              <a:t>읽기 전용 역할 하나입니다. 3rd-party 연결에는 ExternalId로 혼동 대리인을 차단하고, 등록 시점에 실제 assume 검증을 통과해야 연결됩니다. 모니터링 대상 계정에는 쓰기 권한을 요구하지도, 받지도 않습니다(호스트 자신에 대한 단일 문서화 예외는 ADR-015 웹 재시작뿐).</a:t>
+              <a:t>읽기 전용 역할 하나입니다. 3rd-party 연결에는 ExternalId로 혼동 대리인을 차단하고, 등록 시점에 실제 assume 검증을 통과해야 연결됩니다. 모니터링 대상 계정에는 쓰기 권한을 요구하지도, 받지도 않습니다(호스트 자신에 대한 단일 문서화 예외는 웹 재시작뿐).</a:t>
             </a:r>
             <a:endParaRPr lang="en-US" sz="1050" dirty="0"/>
           </a:p>

</xml_diff>